<commit_message>
Update docs for the SDR to CDR rename in error steps and messages
README, architecture-summary.html, the error-codes and Lambda config Word
docs, and the solution deck now quote the new step names ("Opening the
CDR page", "Checking the newest CDR period is published") and message
wording ("CDR table", "CDR row", "CDR period"). The Lambda config doc is
regenerated from the current source with a v1.9 version row. Real names
that still say SDR (the portal's SDR menu link, SELECTOR_SDR_OPTION,
SELECTOR_SDR_TABLE_ROW, Gradwell's SDRs_*.csv file names) are unchanged.

Co-Authored-By: Claude Opus 5.5 <noreply@anthropic.com>
Claude-Session: https://claude.ai/code/session_01P27tKdGGVswUWoj8wk4FXV
</commit_message>
<xml_diff>
--- a/Gradwell-CDR-Pipeline-Solution-Overview.pptx
+++ b/Gradwell-CDR-Pipeline-Solution-Overview.pptx
@@ -9805,7 +9805,7 @@
                 <a:ea typeface="Calibri" pitchFamily="34" charset="-122"/>
                 <a:cs typeface="Calibri" pitchFamily="34" charset="-120"/>
               </a:rPr>
-              <a:t>On the 1st of the month, the newest SDR row should cover the period that just completed</a:t>
+              <a:t>On the 1st of the month, the newest CDR row should cover the period that just completed</a:t>
             </a:r>
             <a:endParaRPr lang="en-US" sz="1500" dirty="0"/>
           </a:p>
@@ -10010,7 +10010,7 @@
                 <a:ea typeface="Courier New" pitchFamily="34" charset="-122"/>
                 <a:cs typeface="Courier New" pitchFamily="34" charset="-120"/>
               </a:rPr>
-              <a:t>IF newest SDR end-date ≠</a:t>
+              <a:t>IF newest CDR end-date ≠</a:t>
             </a:r>
             <a:endParaRPr lang="en-US" sz="1200" dirty="0"/>
           </a:p>

</xml_diff>